<commit_message>
Rename deployment component to Web Server / Secure Gateway
Deployment Architecture (slide 8) and its Markdown source labeled
this component "Reverse Proxy / Load Balancer" — updated to "Web
Server / Secure Gateway (IIS or Nginx)" per Tiger's preferred
terminology, across all three environment columns.

Co-authored-by: Claude <noreply@anthropic.com>
</commit_message>
<xml_diff>
--- a/docs/presentation/Tiger-CS-Application-Architecture.pptx
+++ b/docs/presentation/Tiger-CS-Application-Architecture.pptx
@@ -10516,7 +10516,7 @@
                 <a:ea typeface="Calibri" pitchFamily="34" charset="-122"/>
                 <a:cs typeface="Calibri" pitchFamily="34" charset="-120"/>
               </a:rPr>
-              <a:t>Reverse Proxy / Load Balancer</a:t>
+              <a:t>Web Server / Secure Gateway (IIS or Nginx)</a:t>
             </a:r>
             <a:endParaRPr lang="en-US" sz="1020" dirty="0"/>
           </a:p>
@@ -11071,7 +11071,7 @@
                 <a:ea typeface="Calibri" pitchFamily="34" charset="-122"/>
                 <a:cs typeface="Calibri" pitchFamily="34" charset="-120"/>
               </a:rPr>
-              <a:t>Reverse Proxy / Load Balancer</a:t>
+              <a:t>Web Server / Secure Gateway (IIS or Nginx)</a:t>
             </a:r>
             <a:endParaRPr lang="en-US" sz="1020" dirty="0"/>
           </a:p>
@@ -11626,7 +11626,7 @@
                 <a:ea typeface="Calibri" pitchFamily="34" charset="-122"/>
                 <a:cs typeface="Calibri" pitchFamily="34" charset="-120"/>
               </a:rPr>
-              <a:t>Reverse Proxy / Load Balancer</a:t>
+              <a:t>Web Server / Secure Gateway (IIS or Nginx)</a:t>
             </a:r>
             <a:endParaRPr lang="en-US" sz="1020" dirty="0"/>
           </a:p>

</xml_diff>